<commit_message>
End every study export with a verified Sources and go deeper block.
Each room keeps a sources.json of links opened in 2026-10. Unopened pages stay confirm with no URL. HTML, Markdown, PDF, DOCX, and the teaching deck render that block, and the campus lesson appends the same list.

Co-authored-by: CYPHER0X9 <cipher0x9@users.noreply.github.com>
</commit_message>
<xml_diff>
--- a/downloads/uc-lab-deck.pptx
+++ b/downloads/uc-lab-deck.pptx
@@ -16,6 +16,9 @@
     <p:sldId id="264" r:id="rId15"/>
     <p:sldId id="265" r:id="rId16"/>
     <p:sldId id="266" r:id="rId17"/>
+    <p:sldId id="267" r:id="rId18"/>
+    <p:sldId id="268" r:id="rId19"/>
+    <p:sldId id="269" r:id="rId20"/>
   </p:sldIdLst>
   <p:sldSz cx="9144000" cy="6858000" type="screen4x3"/>
   <p:notesSz cx="6858000" cy="9144000"/>
@@ -3274,6 +3277,452 @@
                 <a:latin typeface="Calibri"/>
               </a:rPr>
               <a:t>Independent free learning project. Not affiliated or endorsed. Contact cyphermonkeylabs.com. Nothing is sold.</a:t>
+            </a:r>
+          </a:p>
+        </p:txBody>
+      </p:sp>
+    </p:spTree>
+  </p:cSld>
+  <p:clrMapOvr>
+    <a:masterClrMapping/>
+  </p:clrMapOvr>
+</p:sld>
+</file>
+
+<file path=ppt/slides/slide12.xml><?xml version="1.0" encoding="utf-8"?>
+<p:sld xmlns:a="http://schemas.openxmlformats.org/drawingml/2006/main" xmlns:p="http://schemas.openxmlformats.org/presentationml/2006/main" xmlns:r="http://schemas.openxmlformats.org/officeDocument/2006/relationships">
+  <p:cSld>
+    <p:spTree>
+      <p:nvGrpSpPr>
+        <p:cNvPr id="1" name=""/>
+        <p:cNvGrpSpPr/>
+        <p:nvPr/>
+      </p:nvGrpSpPr>
+      <p:grpSpPr/>
+      <p:sp>
+        <p:nvSpPr>
+          <p:cNvPr id="2" name="Title 1"/>
+          <p:cNvSpPr>
+            <a:spLocks noGrp="1"/>
+          </p:cNvSpPr>
+          <p:nvPr>
+            <p:ph type="title"/>
+          </p:nvPr>
+        </p:nvSpPr>
+        <p:spPr/>
+        <p:txBody>
+          <a:bodyPr/>
+          <a:lstStyle/>
+          <a:p>
+            <a:r>
+              <a:t>Sources and go deeper</a:t>
+            </a:r>
+          </a:p>
+        </p:txBody>
+      </p:sp>
+      <p:sp>
+        <p:nvSpPr>
+          <p:cNvPr id="3" name="Content Placeholder 2"/>
+          <p:cNvSpPr>
+            <a:spLocks noGrp="1"/>
+          </p:cNvSpPr>
+          <p:nvPr>
+            <p:ph idx="1"/>
+          </p:nvPr>
+        </p:nvSpPr>
+        <p:spPr/>
+        <p:txBody>
+          <a:bodyPr wrap="square"/>
+          <a:lstStyle/>
+          <a:p>
+            <a:r>
+              <a:t>Opened 2026-10. A row marked confirm has no link, because that page was not verified.</a:t>
+            </a:r>
+          </a:p>
+          <a:p>
+            <a:r>
+              <a:rPr sz="1400">
+                <a:hlinkClick r:id="rId2"/>
+              </a:rPr>
+              <a:t>RFC. RFC 3261, SIP</a:t>
+            </a:r>
+            <a:r>
+              <a:rPr sz="1400"/>
+              <a:t>. last checked 2026-10</a:t>
+            </a:r>
+          </a:p>
+          <a:p>
+            <a:r>
+              <a:rPr sz="1400">
+                <a:hlinkClick r:id="rId3"/>
+              </a:rPr>
+              <a:t>RFC. RFC 3264, offer/answer</a:t>
+            </a:r>
+            <a:r>
+              <a:rPr sz="1400"/>
+              <a:t>. last checked 2026-10</a:t>
+            </a:r>
+          </a:p>
+          <a:p>
+            <a:r>
+              <a:rPr sz="1400">
+                <a:hlinkClick r:id="rId4"/>
+              </a:rPr>
+              <a:t>RFC. RFC 3550, RTP</a:t>
+            </a:r>
+            <a:r>
+              <a:rPr sz="1400"/>
+              <a:t>. last checked 2026-10</a:t>
+            </a:r>
+          </a:p>
+          <a:p>
+            <a:r>
+              <a:rPr sz="1400">
+                <a:hlinkClick r:id="rId5"/>
+              </a:rPr>
+              <a:t>RFC. RFC 4566, SDP</a:t>
+            </a:r>
+            <a:r>
+              <a:rPr sz="1400"/>
+              <a:t>. last checked 2026-10</a:t>
+            </a:r>
+          </a:p>
+          <a:p>
+            <a:r>
+              <a:rPr sz="1400">
+                <a:hlinkClick r:id="rId6"/>
+              </a:rPr>
+              <a:t>RFC. RFC 3711, SRTP</a:t>
+            </a:r>
+            <a:r>
+              <a:rPr sz="1400"/>
+              <a:t>. last checked 2026-10</a:t>
+            </a:r>
+          </a:p>
+          <a:p>
+            <a:r>
+              <a:rPr sz="1400">
+                <a:hlinkClick r:id="rId7"/>
+              </a:rPr>
+              <a:t>Cisco. Cisco Unified Communications Manager product support</a:t>
+            </a:r>
+            <a:r>
+              <a:rPr sz="1400"/>
+              <a:t>. last checked 2026-10</a:t>
+            </a:r>
+          </a:p>
+          <a:p>
+            <a:r>
+              <a:rPr sz="1400">
+                <a:hlinkClick r:id="rId8"/>
+              </a:rPr>
+              <a:t>Cisco. System Configuration Guide for CUCM, Release 15</a:t>
+            </a:r>
+            <a:r>
+              <a:rPr sz="1400"/>
+              <a:t>. last checked 2026-10</a:t>
+            </a:r>
+          </a:p>
+          <a:p>
+            <a:r>
+              <a:rPr sz="1400">
+                <a:hlinkClick r:id="rId9"/>
+              </a:rPr>
+              <a:t>Cisco. Cisco Collaboration Preferred Architectures</a:t>
+            </a:r>
+            <a:r>
+              <a:rPr sz="1400"/>
+              <a:t>. last checked 2026-10</a:t>
+            </a:r>
+          </a:p>
+        </p:txBody>
+      </p:sp>
+    </p:spTree>
+  </p:cSld>
+  <p:clrMapOvr>
+    <a:masterClrMapping/>
+  </p:clrMapOvr>
+</p:sld>
+</file>
+
+<file path=ppt/slides/slide13.xml><?xml version="1.0" encoding="utf-8"?>
+<p:sld xmlns:a="http://schemas.openxmlformats.org/drawingml/2006/main" xmlns:p="http://schemas.openxmlformats.org/presentationml/2006/main" xmlns:r="http://schemas.openxmlformats.org/officeDocument/2006/relationships">
+  <p:cSld>
+    <p:spTree>
+      <p:nvGrpSpPr>
+        <p:cNvPr id="1" name=""/>
+        <p:cNvGrpSpPr/>
+        <p:nvPr/>
+      </p:nvGrpSpPr>
+      <p:grpSpPr/>
+      <p:sp>
+        <p:nvSpPr>
+          <p:cNvPr id="2" name="Title 1"/>
+          <p:cNvSpPr>
+            <a:spLocks noGrp="1"/>
+          </p:cNvSpPr>
+          <p:nvPr>
+            <p:ph type="title"/>
+          </p:nvPr>
+        </p:nvSpPr>
+        <p:spPr/>
+        <p:txBody>
+          <a:bodyPr/>
+          <a:lstStyle/>
+          <a:p>
+            <a:r>
+              <a:t>Sources and go deeper, continued</a:t>
+            </a:r>
+          </a:p>
+        </p:txBody>
+      </p:sp>
+      <p:sp>
+        <p:nvSpPr>
+          <p:cNvPr id="3" name="Content Placeholder 2"/>
+          <p:cNvSpPr>
+            <a:spLocks noGrp="1"/>
+          </p:cNvSpPr>
+          <p:nvPr>
+            <p:ph idx="1"/>
+          </p:nvPr>
+        </p:nvSpPr>
+        <p:spPr/>
+        <p:txBody>
+          <a:bodyPr wrap="square"/>
+          <a:lstStyle/>
+          <a:p>
+            <a:r>
+              <a:rPr sz="1400">
+                <a:hlinkClick r:id="rId2"/>
+              </a:rPr>
+              <a:t>Cisco. Preferred Architecture for Cisco Collaboration 15, design overview (PDF)</a:t>
+            </a:r>
+            <a:r>
+              <a:rPr sz="1400"/>
+              <a:t>. last checked 2026-10</a:t>
+            </a:r>
+          </a:p>
+          <a:p>
+            <a:r>
+              <a:rPr sz="1400">
+                <a:hlinkClick r:id="rId3"/>
+              </a:rPr>
+              <a:t>Cisco. Cisco Unified Border Element product support</a:t>
+            </a:r>
+            <a:r>
+              <a:rPr sz="1400"/>
+              <a:t>. last checked 2026-10</a:t>
+            </a:r>
+          </a:p>
+          <a:p>
+            <a:r>
+              <a:rPr sz="1400">
+                <a:hlinkClick r:id="rId4"/>
+              </a:rPr>
+              <a:t>Protocol and ports. CUCM 15 TCP and UDP port usage</a:t>
+            </a:r>
+            <a:r>
+              <a:rPr sz="1400"/>
+              <a:t>. last checked 2026-10</a:t>
+            </a:r>
+          </a:p>
+          <a:p>
+            <a:r>
+              <a:rPr sz="1400">
+                <a:hlinkClick r:id="rId5"/>
+              </a:rPr>
+              <a:t>Protocol and ports. Cisco Expressway IP port usage (X14.3 and X15.0)</a:t>
+            </a:r>
+            <a:r>
+              <a:rPr sz="1400"/>
+              <a:t>. last checked 2026-10</a:t>
+            </a:r>
+          </a:p>
+          <a:p>
+            <a:r>
+              <a:rPr sz="1400">
+                <a:hlinkClick r:id="rId6"/>
+              </a:rPr>
+              <a:t>Protocol and ports. Port reference for Webex Calling</a:t>
+            </a:r>
+            <a:r>
+              <a:rPr sz="1400"/>
+              <a:t>. last checked 2026-10</a:t>
+            </a:r>
+          </a:p>
+          <a:p>
+            <a:r>
+              <a:rPr sz="1400">
+                <a:hlinkClick r:id="rId7"/>
+              </a:rPr>
+              <a:t>Protocol and ports. IANA SIP parameters</a:t>
+            </a:r>
+            <a:r>
+              <a:rPr sz="1400"/>
+              <a:t>. last checked 2026-10</a:t>
+            </a:r>
+          </a:p>
+          <a:p>
+            <a:r>
+              <a:rPr sz="1400">
+                <a:hlinkClick r:id="rId8"/>
+              </a:rPr>
+              <a:t>Protocol and ports. IANA RTP parameters</a:t>
+            </a:r>
+            <a:r>
+              <a:rPr sz="1400"/>
+              <a:t>. last checked 2026-10</a:t>
+            </a:r>
+          </a:p>
+          <a:p>
+            <a:r>
+              <a:rPr sz="1400">
+                <a:hlinkClick r:id="rId9"/>
+              </a:rPr>
+              <a:t>Protocol and ports. IANA service names and port numbers</a:t>
+            </a:r>
+            <a:r>
+              <a:rPr sz="1400"/>
+              <a:t>. last checked 2026-10</a:t>
+            </a:r>
+          </a:p>
+        </p:txBody>
+      </p:sp>
+    </p:spTree>
+  </p:cSld>
+  <p:clrMapOvr>
+    <a:masterClrMapping/>
+  </p:clrMapOvr>
+</p:sld>
+</file>
+
+<file path=ppt/slides/slide14.xml><?xml version="1.0" encoding="utf-8"?>
+<p:sld xmlns:a="http://schemas.openxmlformats.org/drawingml/2006/main" xmlns:p="http://schemas.openxmlformats.org/presentationml/2006/main" xmlns:r="http://schemas.openxmlformats.org/officeDocument/2006/relationships">
+  <p:cSld>
+    <p:spTree>
+      <p:nvGrpSpPr>
+        <p:cNvPr id="1" name=""/>
+        <p:cNvGrpSpPr/>
+        <p:nvPr/>
+      </p:nvGrpSpPr>
+      <p:grpSpPr/>
+      <p:sp>
+        <p:nvSpPr>
+          <p:cNvPr id="2" name="Title 1"/>
+          <p:cNvSpPr>
+            <a:spLocks noGrp="1"/>
+          </p:cNvSpPr>
+          <p:nvPr>
+            <p:ph type="title"/>
+          </p:nvPr>
+        </p:nvSpPr>
+        <p:spPr/>
+        <p:txBody>
+          <a:bodyPr/>
+          <a:lstStyle/>
+          <a:p>
+            <a:r>
+              <a:t>Sources and go deeper, continued</a:t>
+            </a:r>
+          </a:p>
+        </p:txBody>
+      </p:sp>
+      <p:sp>
+        <p:nvSpPr>
+          <p:cNvPr id="3" name="Content Placeholder 2"/>
+          <p:cNvSpPr>
+            <a:spLocks noGrp="1"/>
+          </p:cNvSpPr>
+          <p:nvPr>
+            <p:ph idx="1"/>
+          </p:nvPr>
+        </p:nvSpPr>
+        <p:spPr/>
+        <p:txBody>
+          <a:bodyPr wrap="square"/>
+          <a:lstStyle/>
+          <a:p>
+            <a:r>
+              <a:rPr sz="1400">
+                <a:hlinkClick r:id="rId2"/>
+              </a:rPr>
+              <a:t>Community. Cisco Community, Collaboration knowledge base</a:t>
+            </a:r>
+            <a:r>
+              <a:rPr sz="1400"/>
+              <a:t>. last checked 2026-10</a:t>
+            </a:r>
+          </a:p>
+          <a:p>
+            <a:r>
+              <a:rPr sz="1400">
+                <a:hlinkClick r:id="rId3"/>
+              </a:rPr>
+              <a:t>Wikipedia. Session Initiation Protocol (Wikipedia)</a:t>
+            </a:r>
+            <a:r>
+              <a:rPr sz="1400"/>
+              <a:t>. last checked 2026-10</a:t>
+            </a:r>
+          </a:p>
+          <a:p>
+            <a:r>
+              <a:rPr sz="1400">
+                <a:hlinkClick r:id="rId4"/>
+              </a:rPr>
+              <a:t>Wikipedia. Real-time Transport Protocol (Wikipedia)</a:t>
+            </a:r>
+            <a:r>
+              <a:rPr sz="1400"/>
+              <a:t>. last checked 2026-10</a:t>
+            </a:r>
+          </a:p>
+          <a:p>
+            <a:r>
+              <a:rPr sz="1400">
+                <a:hlinkClick r:id="rId5"/>
+              </a:rPr>
+              <a:t>Wikipedia. Session Description Protocol (Wikipedia)</a:t>
+            </a:r>
+            <a:r>
+              <a:rPr sz="1400"/>
+              <a:t>. last checked 2026-10</a:t>
+            </a:r>
+          </a:p>
+          <a:p>
+            <a:r>
+              <a:rPr sz="1400">
+                <a:hlinkClick r:id="rId6"/>
+              </a:rPr>
+              <a:t>Wikipedia. Voice over IP (Wikipedia)</a:t>
+            </a:r>
+            <a:r>
+              <a:rPr sz="1400"/>
+              <a:t>. last checked 2026-10</a:t>
+            </a:r>
+          </a:p>
+          <a:p>
+            <a:r>
+              <a:rPr sz="1400"/>
+              <a:t>Cisco. Collaboration 12 SRND book. confirm. The historical Collaboration 12 SRND path opened as a product listing, not the design book. Use the Preferred Architecture index, which was opened. last checked 2026-10</a:t>
+            </a:r>
+          </a:p>
+          <a:p>
+            <a:r>
+              <a:rPr sz="1400"/>
+              <a:t>Cisco. Enterprise QoS SRND book. confirm. The Enterprise QoS SRND path returned HTTP 404. last checked 2026-10</a:t>
+            </a:r>
+          </a:p>
+          <a:p>
+            <a:r>
+              <a:rPr sz="1400"/>
+              <a:t>Wikipedia. English Wikipedia article for Cisco Unified Communications Manager. confirm. That title returned HTTP 404. The CUCM disambiguation page is the Wikipedia page that opened. last checked 2026-10</a:t>
+            </a:r>
+          </a:p>
+          <a:p>
+            <a:r>
+              <a:rPr sz="1200"/>
+              <a:t>Independent free learning-only student project. Not affiliated or endorsed. Nothing is sold.</a:t>
             </a:r>
           </a:p>
         </p:txBody>

</xml_diff>

<commit_message>
Round 3: floating menus, read-along, exports, and sources (#18)
* Add floating chrome, read-along glow, and section exports.

The university and campus menus now float with glow and depth, motion respects reduced-motion, and each room section has its own export row. Flagship footers use the three studio icons. The campus checker accepts those official links and the university front door.

Co-authored-by: CYPHER0X9 <cipher0x9@users.noreply.github.com>

* End every study export with a verified Sources and go deeper block.

Each room keeps a sources.json of links opened in 2026-10. Unopened pages stay confirm with no URL. HTML, Markdown, PDF, DOCX, and the teaching deck render that block, and the campus lesson appends the same list.

Co-authored-by: CYPHER0X9 <cipher0x9@users.noreply.github.com>

---------

Co-authored-by: Cursor Agent <cursoragent@cursor.com>
Co-authored-by: CYPHER0X9 <cipher0x9@users.noreply.github.com>
</commit_message>
<xml_diff>
--- a/downloads/uc-lab-deck.pptx
+++ b/downloads/uc-lab-deck.pptx
@@ -16,6 +16,9 @@
     <p:sldId id="264" r:id="rId15"/>
     <p:sldId id="265" r:id="rId16"/>
     <p:sldId id="266" r:id="rId17"/>
+    <p:sldId id="267" r:id="rId18"/>
+    <p:sldId id="268" r:id="rId19"/>
+    <p:sldId id="269" r:id="rId20"/>
   </p:sldIdLst>
   <p:sldSz cx="9144000" cy="6858000" type="screen4x3"/>
   <p:notesSz cx="6858000" cy="9144000"/>
@@ -3274,6 +3277,452 @@
                 <a:latin typeface="Calibri"/>
               </a:rPr>
               <a:t>Independent free learning project. Not affiliated or endorsed. Contact cyphermonkeylabs.com. Nothing is sold.</a:t>
+            </a:r>
+          </a:p>
+        </p:txBody>
+      </p:sp>
+    </p:spTree>
+  </p:cSld>
+  <p:clrMapOvr>
+    <a:masterClrMapping/>
+  </p:clrMapOvr>
+</p:sld>
+</file>
+
+<file path=ppt/slides/slide12.xml><?xml version="1.0" encoding="utf-8"?>
+<p:sld xmlns:a="http://schemas.openxmlformats.org/drawingml/2006/main" xmlns:p="http://schemas.openxmlformats.org/presentationml/2006/main" xmlns:r="http://schemas.openxmlformats.org/officeDocument/2006/relationships">
+  <p:cSld>
+    <p:spTree>
+      <p:nvGrpSpPr>
+        <p:cNvPr id="1" name=""/>
+        <p:cNvGrpSpPr/>
+        <p:nvPr/>
+      </p:nvGrpSpPr>
+      <p:grpSpPr/>
+      <p:sp>
+        <p:nvSpPr>
+          <p:cNvPr id="2" name="Title 1"/>
+          <p:cNvSpPr>
+            <a:spLocks noGrp="1"/>
+          </p:cNvSpPr>
+          <p:nvPr>
+            <p:ph type="title"/>
+          </p:nvPr>
+        </p:nvSpPr>
+        <p:spPr/>
+        <p:txBody>
+          <a:bodyPr/>
+          <a:lstStyle/>
+          <a:p>
+            <a:r>
+              <a:t>Sources and go deeper</a:t>
+            </a:r>
+          </a:p>
+        </p:txBody>
+      </p:sp>
+      <p:sp>
+        <p:nvSpPr>
+          <p:cNvPr id="3" name="Content Placeholder 2"/>
+          <p:cNvSpPr>
+            <a:spLocks noGrp="1"/>
+          </p:cNvSpPr>
+          <p:nvPr>
+            <p:ph idx="1"/>
+          </p:nvPr>
+        </p:nvSpPr>
+        <p:spPr/>
+        <p:txBody>
+          <a:bodyPr wrap="square"/>
+          <a:lstStyle/>
+          <a:p>
+            <a:r>
+              <a:t>Opened 2026-10. A row marked confirm has no link, because that page was not verified.</a:t>
+            </a:r>
+          </a:p>
+          <a:p>
+            <a:r>
+              <a:rPr sz="1400">
+                <a:hlinkClick r:id="rId2"/>
+              </a:rPr>
+              <a:t>RFC. RFC 3261, SIP</a:t>
+            </a:r>
+            <a:r>
+              <a:rPr sz="1400"/>
+              <a:t>. last checked 2026-10</a:t>
+            </a:r>
+          </a:p>
+          <a:p>
+            <a:r>
+              <a:rPr sz="1400">
+                <a:hlinkClick r:id="rId3"/>
+              </a:rPr>
+              <a:t>RFC. RFC 3264, offer/answer</a:t>
+            </a:r>
+            <a:r>
+              <a:rPr sz="1400"/>
+              <a:t>. last checked 2026-10</a:t>
+            </a:r>
+          </a:p>
+          <a:p>
+            <a:r>
+              <a:rPr sz="1400">
+                <a:hlinkClick r:id="rId4"/>
+              </a:rPr>
+              <a:t>RFC. RFC 3550, RTP</a:t>
+            </a:r>
+            <a:r>
+              <a:rPr sz="1400"/>
+              <a:t>. last checked 2026-10</a:t>
+            </a:r>
+          </a:p>
+          <a:p>
+            <a:r>
+              <a:rPr sz="1400">
+                <a:hlinkClick r:id="rId5"/>
+              </a:rPr>
+              <a:t>RFC. RFC 4566, SDP</a:t>
+            </a:r>
+            <a:r>
+              <a:rPr sz="1400"/>
+              <a:t>. last checked 2026-10</a:t>
+            </a:r>
+          </a:p>
+          <a:p>
+            <a:r>
+              <a:rPr sz="1400">
+                <a:hlinkClick r:id="rId6"/>
+              </a:rPr>
+              <a:t>RFC. RFC 3711, SRTP</a:t>
+            </a:r>
+            <a:r>
+              <a:rPr sz="1400"/>
+              <a:t>. last checked 2026-10</a:t>
+            </a:r>
+          </a:p>
+          <a:p>
+            <a:r>
+              <a:rPr sz="1400">
+                <a:hlinkClick r:id="rId7"/>
+              </a:rPr>
+              <a:t>Cisco. Cisco Unified Communications Manager product support</a:t>
+            </a:r>
+            <a:r>
+              <a:rPr sz="1400"/>
+              <a:t>. last checked 2026-10</a:t>
+            </a:r>
+          </a:p>
+          <a:p>
+            <a:r>
+              <a:rPr sz="1400">
+                <a:hlinkClick r:id="rId8"/>
+              </a:rPr>
+              <a:t>Cisco. System Configuration Guide for CUCM, Release 15</a:t>
+            </a:r>
+            <a:r>
+              <a:rPr sz="1400"/>
+              <a:t>. last checked 2026-10</a:t>
+            </a:r>
+          </a:p>
+          <a:p>
+            <a:r>
+              <a:rPr sz="1400">
+                <a:hlinkClick r:id="rId9"/>
+              </a:rPr>
+              <a:t>Cisco. Cisco Collaboration Preferred Architectures</a:t>
+            </a:r>
+            <a:r>
+              <a:rPr sz="1400"/>
+              <a:t>. last checked 2026-10</a:t>
+            </a:r>
+          </a:p>
+        </p:txBody>
+      </p:sp>
+    </p:spTree>
+  </p:cSld>
+  <p:clrMapOvr>
+    <a:masterClrMapping/>
+  </p:clrMapOvr>
+</p:sld>
+</file>
+
+<file path=ppt/slides/slide13.xml><?xml version="1.0" encoding="utf-8"?>
+<p:sld xmlns:a="http://schemas.openxmlformats.org/drawingml/2006/main" xmlns:p="http://schemas.openxmlformats.org/presentationml/2006/main" xmlns:r="http://schemas.openxmlformats.org/officeDocument/2006/relationships">
+  <p:cSld>
+    <p:spTree>
+      <p:nvGrpSpPr>
+        <p:cNvPr id="1" name=""/>
+        <p:cNvGrpSpPr/>
+        <p:nvPr/>
+      </p:nvGrpSpPr>
+      <p:grpSpPr/>
+      <p:sp>
+        <p:nvSpPr>
+          <p:cNvPr id="2" name="Title 1"/>
+          <p:cNvSpPr>
+            <a:spLocks noGrp="1"/>
+          </p:cNvSpPr>
+          <p:nvPr>
+            <p:ph type="title"/>
+          </p:nvPr>
+        </p:nvSpPr>
+        <p:spPr/>
+        <p:txBody>
+          <a:bodyPr/>
+          <a:lstStyle/>
+          <a:p>
+            <a:r>
+              <a:t>Sources and go deeper, continued</a:t>
+            </a:r>
+          </a:p>
+        </p:txBody>
+      </p:sp>
+      <p:sp>
+        <p:nvSpPr>
+          <p:cNvPr id="3" name="Content Placeholder 2"/>
+          <p:cNvSpPr>
+            <a:spLocks noGrp="1"/>
+          </p:cNvSpPr>
+          <p:nvPr>
+            <p:ph idx="1"/>
+          </p:nvPr>
+        </p:nvSpPr>
+        <p:spPr/>
+        <p:txBody>
+          <a:bodyPr wrap="square"/>
+          <a:lstStyle/>
+          <a:p>
+            <a:r>
+              <a:rPr sz="1400">
+                <a:hlinkClick r:id="rId2"/>
+              </a:rPr>
+              <a:t>Cisco. Preferred Architecture for Cisco Collaboration 15, design overview (PDF)</a:t>
+            </a:r>
+            <a:r>
+              <a:rPr sz="1400"/>
+              <a:t>. last checked 2026-10</a:t>
+            </a:r>
+          </a:p>
+          <a:p>
+            <a:r>
+              <a:rPr sz="1400">
+                <a:hlinkClick r:id="rId3"/>
+              </a:rPr>
+              <a:t>Cisco. Cisco Unified Border Element product support</a:t>
+            </a:r>
+            <a:r>
+              <a:rPr sz="1400"/>
+              <a:t>. last checked 2026-10</a:t>
+            </a:r>
+          </a:p>
+          <a:p>
+            <a:r>
+              <a:rPr sz="1400">
+                <a:hlinkClick r:id="rId4"/>
+              </a:rPr>
+              <a:t>Protocol and ports. CUCM 15 TCP and UDP port usage</a:t>
+            </a:r>
+            <a:r>
+              <a:rPr sz="1400"/>
+              <a:t>. last checked 2026-10</a:t>
+            </a:r>
+          </a:p>
+          <a:p>
+            <a:r>
+              <a:rPr sz="1400">
+                <a:hlinkClick r:id="rId5"/>
+              </a:rPr>
+              <a:t>Protocol and ports. Cisco Expressway IP port usage (X14.3 and X15.0)</a:t>
+            </a:r>
+            <a:r>
+              <a:rPr sz="1400"/>
+              <a:t>. last checked 2026-10</a:t>
+            </a:r>
+          </a:p>
+          <a:p>
+            <a:r>
+              <a:rPr sz="1400">
+                <a:hlinkClick r:id="rId6"/>
+              </a:rPr>
+              <a:t>Protocol and ports. Port reference for Webex Calling</a:t>
+            </a:r>
+            <a:r>
+              <a:rPr sz="1400"/>
+              <a:t>. last checked 2026-10</a:t>
+            </a:r>
+          </a:p>
+          <a:p>
+            <a:r>
+              <a:rPr sz="1400">
+                <a:hlinkClick r:id="rId7"/>
+              </a:rPr>
+              <a:t>Protocol and ports. IANA SIP parameters</a:t>
+            </a:r>
+            <a:r>
+              <a:rPr sz="1400"/>
+              <a:t>. last checked 2026-10</a:t>
+            </a:r>
+          </a:p>
+          <a:p>
+            <a:r>
+              <a:rPr sz="1400">
+                <a:hlinkClick r:id="rId8"/>
+              </a:rPr>
+              <a:t>Protocol and ports. IANA RTP parameters</a:t>
+            </a:r>
+            <a:r>
+              <a:rPr sz="1400"/>
+              <a:t>. last checked 2026-10</a:t>
+            </a:r>
+          </a:p>
+          <a:p>
+            <a:r>
+              <a:rPr sz="1400">
+                <a:hlinkClick r:id="rId9"/>
+              </a:rPr>
+              <a:t>Protocol and ports. IANA service names and port numbers</a:t>
+            </a:r>
+            <a:r>
+              <a:rPr sz="1400"/>
+              <a:t>. last checked 2026-10</a:t>
+            </a:r>
+          </a:p>
+        </p:txBody>
+      </p:sp>
+    </p:spTree>
+  </p:cSld>
+  <p:clrMapOvr>
+    <a:masterClrMapping/>
+  </p:clrMapOvr>
+</p:sld>
+</file>
+
+<file path=ppt/slides/slide14.xml><?xml version="1.0" encoding="utf-8"?>
+<p:sld xmlns:a="http://schemas.openxmlformats.org/drawingml/2006/main" xmlns:p="http://schemas.openxmlformats.org/presentationml/2006/main" xmlns:r="http://schemas.openxmlformats.org/officeDocument/2006/relationships">
+  <p:cSld>
+    <p:spTree>
+      <p:nvGrpSpPr>
+        <p:cNvPr id="1" name=""/>
+        <p:cNvGrpSpPr/>
+        <p:nvPr/>
+      </p:nvGrpSpPr>
+      <p:grpSpPr/>
+      <p:sp>
+        <p:nvSpPr>
+          <p:cNvPr id="2" name="Title 1"/>
+          <p:cNvSpPr>
+            <a:spLocks noGrp="1"/>
+          </p:cNvSpPr>
+          <p:nvPr>
+            <p:ph type="title"/>
+          </p:nvPr>
+        </p:nvSpPr>
+        <p:spPr/>
+        <p:txBody>
+          <a:bodyPr/>
+          <a:lstStyle/>
+          <a:p>
+            <a:r>
+              <a:t>Sources and go deeper, continued</a:t>
+            </a:r>
+          </a:p>
+        </p:txBody>
+      </p:sp>
+      <p:sp>
+        <p:nvSpPr>
+          <p:cNvPr id="3" name="Content Placeholder 2"/>
+          <p:cNvSpPr>
+            <a:spLocks noGrp="1"/>
+          </p:cNvSpPr>
+          <p:nvPr>
+            <p:ph idx="1"/>
+          </p:nvPr>
+        </p:nvSpPr>
+        <p:spPr/>
+        <p:txBody>
+          <a:bodyPr wrap="square"/>
+          <a:lstStyle/>
+          <a:p>
+            <a:r>
+              <a:rPr sz="1400">
+                <a:hlinkClick r:id="rId2"/>
+              </a:rPr>
+              <a:t>Community. Cisco Community, Collaboration knowledge base</a:t>
+            </a:r>
+            <a:r>
+              <a:rPr sz="1400"/>
+              <a:t>. last checked 2026-10</a:t>
+            </a:r>
+          </a:p>
+          <a:p>
+            <a:r>
+              <a:rPr sz="1400">
+                <a:hlinkClick r:id="rId3"/>
+              </a:rPr>
+              <a:t>Wikipedia. Session Initiation Protocol (Wikipedia)</a:t>
+            </a:r>
+            <a:r>
+              <a:rPr sz="1400"/>
+              <a:t>. last checked 2026-10</a:t>
+            </a:r>
+          </a:p>
+          <a:p>
+            <a:r>
+              <a:rPr sz="1400">
+                <a:hlinkClick r:id="rId4"/>
+              </a:rPr>
+              <a:t>Wikipedia. Real-time Transport Protocol (Wikipedia)</a:t>
+            </a:r>
+            <a:r>
+              <a:rPr sz="1400"/>
+              <a:t>. last checked 2026-10</a:t>
+            </a:r>
+          </a:p>
+          <a:p>
+            <a:r>
+              <a:rPr sz="1400">
+                <a:hlinkClick r:id="rId5"/>
+              </a:rPr>
+              <a:t>Wikipedia. Session Description Protocol (Wikipedia)</a:t>
+            </a:r>
+            <a:r>
+              <a:rPr sz="1400"/>
+              <a:t>. last checked 2026-10</a:t>
+            </a:r>
+          </a:p>
+          <a:p>
+            <a:r>
+              <a:rPr sz="1400">
+                <a:hlinkClick r:id="rId6"/>
+              </a:rPr>
+              <a:t>Wikipedia. Voice over IP (Wikipedia)</a:t>
+            </a:r>
+            <a:r>
+              <a:rPr sz="1400"/>
+              <a:t>. last checked 2026-10</a:t>
+            </a:r>
+          </a:p>
+          <a:p>
+            <a:r>
+              <a:rPr sz="1400"/>
+              <a:t>Cisco. Collaboration 12 SRND book. confirm. The historical Collaboration 12 SRND path opened as a product listing, not the design book. Use the Preferred Architecture index, which was opened. last checked 2026-10</a:t>
+            </a:r>
+          </a:p>
+          <a:p>
+            <a:r>
+              <a:rPr sz="1400"/>
+              <a:t>Cisco. Enterprise QoS SRND book. confirm. The Enterprise QoS SRND path returned HTTP 404. last checked 2026-10</a:t>
+            </a:r>
+          </a:p>
+          <a:p>
+            <a:r>
+              <a:rPr sz="1400"/>
+              <a:t>Wikipedia. English Wikipedia article for Cisco Unified Communications Manager. confirm. That title returned HTTP 404. The CUCM disambiguation page is the Wikipedia page that opened. last checked 2026-10</a:t>
+            </a:r>
+          </a:p>
+          <a:p>
+            <a:r>
+              <a:rPr sz="1200"/>
+              <a:t>Independent free learning-only student project. Not affiliated or endorsed. Nothing is sold.</a:t>
             </a:r>
           </a:p>
         </p:txBody>

</xml_diff>

<commit_message>
Add emergency calling, recording, and open-telephony tracks.
Three new study tracks and an updated ecosystem page stay inside the existing generator so the menu, counts, footer, and source blocks stay consistent.

Co-authored-by: CYPHER0X9 <cipher0x9@users.noreply.github.com>
</commit_message>
<xml_diff>
--- a/downloads/uc-lab-deck.pptx
+++ b/downloads/uc-lab-deck.pptx
@@ -19,6 +19,9 @@
     <p:sldId id="267" r:id="rId18"/>
     <p:sldId id="268" r:id="rId19"/>
     <p:sldId id="269" r:id="rId20"/>
+    <p:sldId id="270" r:id="rId21"/>
+    <p:sldId id="271" r:id="rId22"/>
+    <p:sldId id="272" r:id="rId23"/>
   </p:sldIdLst>
   <p:sldSz cx="9144000" cy="6858000" type="screen4x3"/>
   <p:notesSz cx="6858000" cy="9144000"/>
@@ -3252,7 +3255,7 @@
               <a:rPr sz="2000">
                 <a:latin typeface="Calibri"/>
               </a:rPr>
-              <a:t>Disclaimer</a:t>
+              <a:t>Emergency calling</a:t>
             </a:r>
           </a:p>
         </p:txBody>
@@ -3276,7 +3279,7 @@
               <a:rPr sz="2000">
                 <a:latin typeface="Calibri"/>
               </a:rPr>
-              <a:t>Independent free learning project. Not affiliated or endorsed. Contact cyphermonkeylabs.com. Nothing is sold.</a:t>
+              <a:t>Study notes. Direct dial, Emergency Responder, ELIN callback. Not legal advice.</a:t>
             </a:r>
           </a:p>
         </p:txBody>
@@ -3315,7 +3318,10 @@
           <a:lstStyle/>
           <a:p>
             <a:r>
-              <a:t>Sources and go deeper</a:t>
+              <a:rPr sz="2000">
+                <a:latin typeface="Calibri"/>
+              </a:rPr>
+              <a:t>Call recording</a:t>
             </a:r>
           </a:p>
         </p:txBody>
@@ -3332,107 +3338,14 @@
         </p:nvSpPr>
         <p:spPr/>
         <p:txBody>
-          <a:bodyPr wrap="square"/>
-          <a:lstStyle/>
-          <a:p>
-            <a:r>
-              <a:t>Opened 2026-10. A row marked confirm has no link, because that page was not verified.</a:t>
-            </a:r>
-          </a:p>
-          <a:p>
-            <a:r>
-              <a:rPr sz="1400">
-                <a:hlinkClick r:id="rId2"/>
-              </a:rPr>
-              <a:t>RFC. RFC 3261, SIP</a:t>
-            </a:r>
-            <a:r>
-              <a:rPr sz="1400"/>
-              <a:t>. last checked 2026-10</a:t>
-            </a:r>
-          </a:p>
-          <a:p>
-            <a:r>
-              <a:rPr sz="1400">
-                <a:hlinkClick r:id="rId3"/>
-              </a:rPr>
-              <a:t>RFC. RFC 3264, offer/answer</a:t>
-            </a:r>
-            <a:r>
-              <a:rPr sz="1400"/>
-              <a:t>. last checked 2026-10</a:t>
-            </a:r>
-          </a:p>
-          <a:p>
-            <a:r>
-              <a:rPr sz="1400">
-                <a:hlinkClick r:id="rId4"/>
-              </a:rPr>
-              <a:t>RFC. RFC 3550, RTP</a:t>
-            </a:r>
-            <a:r>
-              <a:rPr sz="1400"/>
-              <a:t>. last checked 2026-10</a:t>
-            </a:r>
-          </a:p>
-          <a:p>
-            <a:r>
-              <a:rPr sz="1400">
-                <a:hlinkClick r:id="rId5"/>
-              </a:rPr>
-              <a:t>RFC. RFC 4566, SDP</a:t>
-            </a:r>
-            <a:r>
-              <a:rPr sz="1400"/>
-              <a:t>. last checked 2026-10</a:t>
-            </a:r>
-          </a:p>
-          <a:p>
-            <a:r>
-              <a:rPr sz="1400">
-                <a:hlinkClick r:id="rId6"/>
-              </a:rPr>
-              <a:t>RFC. RFC 3711, SRTP</a:t>
-            </a:r>
-            <a:r>
-              <a:rPr sz="1400"/>
-              <a:t>. last checked 2026-10</a:t>
-            </a:r>
-          </a:p>
-          <a:p>
-            <a:r>
-              <a:rPr sz="1400">
-                <a:hlinkClick r:id="rId7"/>
-              </a:rPr>
-              <a:t>Cisco. Cisco Unified Communications Manager product support</a:t>
-            </a:r>
-            <a:r>
-              <a:rPr sz="1400"/>
-              <a:t>. last checked 2026-10</a:t>
-            </a:r>
-          </a:p>
-          <a:p>
-            <a:r>
-              <a:rPr sz="1400">
-                <a:hlinkClick r:id="rId8"/>
-              </a:rPr>
-              <a:t>Cisco. System Configuration Guide for CUCM, Release 15</a:t>
-            </a:r>
-            <a:r>
-              <a:rPr sz="1400"/>
-              <a:t>. last checked 2026-10</a:t>
-            </a:r>
-          </a:p>
-          <a:p>
-            <a:r>
-              <a:rPr sz="1400">
-                <a:hlinkClick r:id="rId9"/>
-              </a:rPr>
-              <a:t>Cisco. Cisco Collaboration Preferred Architectures</a:t>
-            </a:r>
-            <a:r>
-              <a:rPr sz="1400"/>
-              <a:t>. last checked 2026-10</a:t>
+          <a:bodyPr/>
+          <a:lstStyle/>
+          <a:p>
+            <a:r>
+              <a:rPr sz="2000">
+                <a:latin typeface="Calibri"/>
+              </a:rPr>
+              <a:t>Phone fork or gateway fork. SIPREC is a separate session.</a:t>
             </a:r>
           </a:p>
         </p:txBody>
@@ -3471,7 +3384,10 @@
           <a:lstStyle/>
           <a:p>
             <a:r>
-              <a:t>Sources and go deeper, continued</a:t>
+              <a:rPr sz="2000">
+                <a:latin typeface="Calibri"/>
+              </a:rPr>
+              <a:t>Open bridges</a:t>
             </a:r>
           </a:p>
         </p:txBody>
@@ -3488,102 +3404,14 @@
         </p:nvSpPr>
         <p:spPr/>
         <p:txBody>
-          <a:bodyPr wrap="square"/>
-          <a:lstStyle/>
-          <a:p>
-            <a:r>
-              <a:rPr sz="1400">
-                <a:hlinkClick r:id="rId2"/>
-              </a:rPr>
-              <a:t>Cisco. Preferred Architecture for Cisco Collaboration 15, design overview (PDF)</a:t>
-            </a:r>
-            <a:r>
-              <a:rPr sz="1400"/>
-              <a:t>. last checked 2026-10</a:t>
-            </a:r>
-          </a:p>
-          <a:p>
-            <a:r>
-              <a:rPr sz="1400">
-                <a:hlinkClick r:id="rId3"/>
-              </a:rPr>
-              <a:t>Cisco. Cisco Unified Border Element product support</a:t>
-            </a:r>
-            <a:r>
-              <a:rPr sz="1400"/>
-              <a:t>. last checked 2026-10</a:t>
-            </a:r>
-          </a:p>
-          <a:p>
-            <a:r>
-              <a:rPr sz="1400">
-                <a:hlinkClick r:id="rId4"/>
-              </a:rPr>
-              <a:t>Protocol and ports. CUCM 15 TCP and UDP port usage</a:t>
-            </a:r>
-            <a:r>
-              <a:rPr sz="1400"/>
-              <a:t>. last checked 2026-10</a:t>
-            </a:r>
-          </a:p>
-          <a:p>
-            <a:r>
-              <a:rPr sz="1400">
-                <a:hlinkClick r:id="rId5"/>
-              </a:rPr>
-              <a:t>Protocol and ports. Cisco Expressway IP port usage (X14.3 and X15.0)</a:t>
-            </a:r>
-            <a:r>
-              <a:rPr sz="1400"/>
-              <a:t>. last checked 2026-10</a:t>
-            </a:r>
-          </a:p>
-          <a:p>
-            <a:r>
-              <a:rPr sz="1400">
-                <a:hlinkClick r:id="rId6"/>
-              </a:rPr>
-              <a:t>Protocol and ports. Port reference for Webex Calling</a:t>
-            </a:r>
-            <a:r>
-              <a:rPr sz="1400"/>
-              <a:t>. last checked 2026-10</a:t>
-            </a:r>
-          </a:p>
-          <a:p>
-            <a:r>
-              <a:rPr sz="1400">
-                <a:hlinkClick r:id="rId7"/>
-              </a:rPr>
-              <a:t>Protocol and ports. IANA SIP parameters</a:t>
-            </a:r>
-            <a:r>
-              <a:rPr sz="1400"/>
-              <a:t>. last checked 2026-10</a:t>
-            </a:r>
-          </a:p>
-          <a:p>
-            <a:r>
-              <a:rPr sz="1400">
-                <a:hlinkClick r:id="rId8"/>
-              </a:rPr>
-              <a:t>Protocol and ports. IANA RTP parameters</a:t>
-            </a:r>
-            <a:r>
-              <a:rPr sz="1400"/>
-              <a:t>. last checked 2026-10</a:t>
-            </a:r>
-          </a:p>
-          <a:p>
-            <a:r>
-              <a:rPr sz="1400">
-                <a:hlinkClick r:id="rId9"/>
-              </a:rPr>
-              <a:t>Protocol and ports. IANA service names and port numbers</a:t>
-            </a:r>
-            <a:r>
-              <a:rPr sz="1400"/>
-              <a:t>. last checked 2026-10</a:t>
+          <a:bodyPr/>
+          <a:lstStyle/>
+          <a:p>
+            <a:r>
+              <a:rPr sz="2000">
+                <a:latin typeface="Calibri"/>
+              </a:rPr>
+              <a:t>SIP trunk, Asterisk or FreeSWITCH, WebRTC through a gateway.</a:t>
             </a:r>
           </a:p>
         </p:txBody>
@@ -3597,6 +3425,379 @@
 </file>
 
 <file path=ppt/slides/slide14.xml><?xml version="1.0" encoding="utf-8"?>
+<p:sld xmlns:a="http://schemas.openxmlformats.org/drawingml/2006/main" xmlns:p="http://schemas.openxmlformats.org/presentationml/2006/main" xmlns:r="http://schemas.openxmlformats.org/officeDocument/2006/relationships">
+  <p:cSld>
+    <p:spTree>
+      <p:nvGrpSpPr>
+        <p:cNvPr id="1" name=""/>
+        <p:cNvGrpSpPr/>
+        <p:nvPr/>
+      </p:nvGrpSpPr>
+      <p:grpSpPr/>
+      <p:sp>
+        <p:nvSpPr>
+          <p:cNvPr id="2" name="Title 1"/>
+          <p:cNvSpPr>
+            <a:spLocks noGrp="1"/>
+          </p:cNvSpPr>
+          <p:nvPr>
+            <p:ph type="title"/>
+          </p:nvPr>
+        </p:nvSpPr>
+        <p:spPr/>
+        <p:txBody>
+          <a:bodyPr/>
+          <a:lstStyle/>
+          <a:p>
+            <a:r>
+              <a:rPr sz="2000">
+                <a:latin typeface="Calibri"/>
+              </a:rPr>
+              <a:t>Disclaimer</a:t>
+            </a:r>
+          </a:p>
+        </p:txBody>
+      </p:sp>
+      <p:sp>
+        <p:nvSpPr>
+          <p:cNvPr id="3" name="Content Placeholder 2"/>
+          <p:cNvSpPr>
+            <a:spLocks noGrp="1"/>
+          </p:cNvSpPr>
+          <p:nvPr>
+            <p:ph idx="1"/>
+          </p:nvPr>
+        </p:nvSpPr>
+        <p:spPr/>
+        <p:txBody>
+          <a:bodyPr/>
+          <a:lstStyle/>
+          <a:p>
+            <a:r>
+              <a:rPr sz="2000">
+                <a:latin typeface="Calibri"/>
+              </a:rPr>
+              <a:t>Independent free learning project. Not affiliated or endorsed. Not legal advice. Contact cyphermonkeylabs.com. Nothing is sold.</a:t>
+            </a:r>
+          </a:p>
+        </p:txBody>
+      </p:sp>
+    </p:spTree>
+  </p:cSld>
+  <p:clrMapOvr>
+    <a:masterClrMapping/>
+  </p:clrMapOvr>
+</p:sld>
+</file>
+
+<file path=ppt/slides/slide15.xml><?xml version="1.0" encoding="utf-8"?>
+<p:sld xmlns:a="http://schemas.openxmlformats.org/drawingml/2006/main" xmlns:p="http://schemas.openxmlformats.org/presentationml/2006/main" xmlns:r="http://schemas.openxmlformats.org/officeDocument/2006/relationships">
+  <p:cSld>
+    <p:spTree>
+      <p:nvGrpSpPr>
+        <p:cNvPr id="1" name=""/>
+        <p:cNvGrpSpPr/>
+        <p:nvPr/>
+      </p:nvGrpSpPr>
+      <p:grpSpPr/>
+      <p:sp>
+        <p:nvSpPr>
+          <p:cNvPr id="2" name="Title 1"/>
+          <p:cNvSpPr>
+            <a:spLocks noGrp="1"/>
+          </p:cNvSpPr>
+          <p:nvPr>
+            <p:ph type="title"/>
+          </p:nvPr>
+        </p:nvSpPr>
+        <p:spPr/>
+        <p:txBody>
+          <a:bodyPr/>
+          <a:lstStyle/>
+          <a:p>
+            <a:r>
+              <a:t>Sources and go deeper</a:t>
+            </a:r>
+          </a:p>
+        </p:txBody>
+      </p:sp>
+      <p:sp>
+        <p:nvSpPr>
+          <p:cNvPr id="3" name="Content Placeholder 2"/>
+          <p:cNvSpPr>
+            <a:spLocks noGrp="1"/>
+          </p:cNvSpPr>
+          <p:nvPr>
+            <p:ph idx="1"/>
+          </p:nvPr>
+        </p:nvSpPr>
+        <p:spPr/>
+        <p:txBody>
+          <a:bodyPr wrap="square"/>
+          <a:lstStyle/>
+          <a:p>
+            <a:r>
+              <a:t>Opened 2026-10. A row marked confirm has no link, because that page was not verified.</a:t>
+            </a:r>
+          </a:p>
+          <a:p>
+            <a:r>
+              <a:rPr sz="1400">
+                <a:hlinkClick r:id="rId2"/>
+              </a:rPr>
+              <a:t>RFC. RFC 3261, SIP</a:t>
+            </a:r>
+            <a:r>
+              <a:rPr sz="1400"/>
+              <a:t>. last checked 2026-10</a:t>
+            </a:r>
+          </a:p>
+          <a:p>
+            <a:r>
+              <a:rPr sz="1400">
+                <a:hlinkClick r:id="rId3"/>
+              </a:rPr>
+              <a:t>RFC. RFC 3264, offer/answer</a:t>
+            </a:r>
+            <a:r>
+              <a:rPr sz="1400"/>
+              <a:t>. last checked 2026-10</a:t>
+            </a:r>
+          </a:p>
+          <a:p>
+            <a:r>
+              <a:rPr sz="1400">
+                <a:hlinkClick r:id="rId4"/>
+              </a:rPr>
+              <a:t>RFC. RFC 3550, RTP</a:t>
+            </a:r>
+            <a:r>
+              <a:rPr sz="1400"/>
+              <a:t>. last checked 2026-10</a:t>
+            </a:r>
+          </a:p>
+          <a:p>
+            <a:r>
+              <a:rPr sz="1400">
+                <a:hlinkClick r:id="rId5"/>
+              </a:rPr>
+              <a:t>RFC. RFC 4566, SDP</a:t>
+            </a:r>
+            <a:r>
+              <a:rPr sz="1400"/>
+              <a:t>. last checked 2026-10</a:t>
+            </a:r>
+          </a:p>
+          <a:p>
+            <a:r>
+              <a:rPr sz="1400">
+                <a:hlinkClick r:id="rId6"/>
+              </a:rPr>
+              <a:t>RFC. RFC 3711, SRTP</a:t>
+            </a:r>
+            <a:r>
+              <a:rPr sz="1400"/>
+              <a:t>. last checked 2026-10</a:t>
+            </a:r>
+          </a:p>
+          <a:p>
+            <a:r>
+              <a:rPr sz="1400">
+                <a:hlinkClick r:id="rId7"/>
+              </a:rPr>
+              <a:t>Cisco. Cisco Unified Communications Manager product support</a:t>
+            </a:r>
+            <a:r>
+              <a:rPr sz="1400"/>
+              <a:t>. last checked 2026-10</a:t>
+            </a:r>
+          </a:p>
+          <a:p>
+            <a:r>
+              <a:rPr sz="1400">
+                <a:hlinkClick r:id="rId8"/>
+              </a:rPr>
+              <a:t>Cisco. System Configuration Guide for CUCM, Release 15</a:t>
+            </a:r>
+            <a:r>
+              <a:rPr sz="1400"/>
+              <a:t>. last checked 2026-10</a:t>
+            </a:r>
+          </a:p>
+          <a:p>
+            <a:r>
+              <a:rPr sz="1400">
+                <a:hlinkClick r:id="rId9"/>
+              </a:rPr>
+              <a:t>Cisco. Cisco Collaboration Preferred Architectures</a:t>
+            </a:r>
+            <a:r>
+              <a:rPr sz="1400"/>
+              <a:t>. last checked 2026-10</a:t>
+            </a:r>
+          </a:p>
+        </p:txBody>
+      </p:sp>
+    </p:spTree>
+  </p:cSld>
+  <p:clrMapOvr>
+    <a:masterClrMapping/>
+  </p:clrMapOvr>
+</p:sld>
+</file>
+
+<file path=ppt/slides/slide16.xml><?xml version="1.0" encoding="utf-8"?>
+<p:sld xmlns:a="http://schemas.openxmlformats.org/drawingml/2006/main" xmlns:p="http://schemas.openxmlformats.org/presentationml/2006/main" xmlns:r="http://schemas.openxmlformats.org/officeDocument/2006/relationships">
+  <p:cSld>
+    <p:spTree>
+      <p:nvGrpSpPr>
+        <p:cNvPr id="1" name=""/>
+        <p:cNvGrpSpPr/>
+        <p:nvPr/>
+      </p:nvGrpSpPr>
+      <p:grpSpPr/>
+      <p:sp>
+        <p:nvSpPr>
+          <p:cNvPr id="2" name="Title 1"/>
+          <p:cNvSpPr>
+            <a:spLocks noGrp="1"/>
+          </p:cNvSpPr>
+          <p:nvPr>
+            <p:ph type="title"/>
+          </p:nvPr>
+        </p:nvSpPr>
+        <p:spPr/>
+        <p:txBody>
+          <a:bodyPr/>
+          <a:lstStyle/>
+          <a:p>
+            <a:r>
+              <a:t>Sources and go deeper, continued</a:t>
+            </a:r>
+          </a:p>
+        </p:txBody>
+      </p:sp>
+      <p:sp>
+        <p:nvSpPr>
+          <p:cNvPr id="3" name="Content Placeholder 2"/>
+          <p:cNvSpPr>
+            <a:spLocks noGrp="1"/>
+          </p:cNvSpPr>
+          <p:nvPr>
+            <p:ph idx="1"/>
+          </p:nvPr>
+        </p:nvSpPr>
+        <p:spPr/>
+        <p:txBody>
+          <a:bodyPr wrap="square"/>
+          <a:lstStyle/>
+          <a:p>
+            <a:r>
+              <a:rPr sz="1400">
+                <a:hlinkClick r:id="rId2"/>
+              </a:rPr>
+              <a:t>Cisco. Preferred Architecture for Cisco Collaboration 15, design overview (PDF)</a:t>
+            </a:r>
+            <a:r>
+              <a:rPr sz="1400"/>
+              <a:t>. last checked 2026-10</a:t>
+            </a:r>
+          </a:p>
+          <a:p>
+            <a:r>
+              <a:rPr sz="1400">
+                <a:hlinkClick r:id="rId3"/>
+              </a:rPr>
+              <a:t>Cisco. Cisco Unified Border Element product support</a:t>
+            </a:r>
+            <a:r>
+              <a:rPr sz="1400"/>
+              <a:t>. last checked 2026-10</a:t>
+            </a:r>
+          </a:p>
+          <a:p>
+            <a:r>
+              <a:rPr sz="1400">
+                <a:hlinkClick r:id="rId4"/>
+              </a:rPr>
+              <a:t>Protocol and ports. CUCM 15 TCP and UDP port usage</a:t>
+            </a:r>
+            <a:r>
+              <a:rPr sz="1400"/>
+              <a:t>. last checked 2026-10</a:t>
+            </a:r>
+          </a:p>
+          <a:p>
+            <a:r>
+              <a:rPr sz="1400">
+                <a:hlinkClick r:id="rId5"/>
+              </a:rPr>
+              <a:t>Protocol and ports. Cisco Expressway IP port usage (X14.3 and X15.0)</a:t>
+            </a:r>
+            <a:r>
+              <a:rPr sz="1400"/>
+              <a:t>. last checked 2026-10</a:t>
+            </a:r>
+          </a:p>
+          <a:p>
+            <a:r>
+              <a:rPr sz="1400">
+                <a:hlinkClick r:id="rId6"/>
+              </a:rPr>
+              <a:t>Protocol and ports. Port reference for Webex Calling</a:t>
+            </a:r>
+            <a:r>
+              <a:rPr sz="1400"/>
+              <a:t>. last checked 2026-10</a:t>
+            </a:r>
+          </a:p>
+          <a:p>
+            <a:r>
+              <a:rPr sz="1400">
+                <a:hlinkClick r:id="rId7"/>
+              </a:rPr>
+              <a:t>Protocol and ports. IANA SIP parameters</a:t>
+            </a:r>
+            <a:r>
+              <a:rPr sz="1400"/>
+              <a:t>. last checked 2026-10</a:t>
+            </a:r>
+          </a:p>
+          <a:p>
+            <a:r>
+              <a:rPr sz="1400">
+                <a:hlinkClick r:id="rId8"/>
+              </a:rPr>
+              <a:t>Protocol and ports. IANA RTP parameters</a:t>
+            </a:r>
+            <a:r>
+              <a:rPr sz="1400"/>
+              <a:t>. last checked 2026-10</a:t>
+            </a:r>
+          </a:p>
+          <a:p>
+            <a:r>
+              <a:rPr sz="1400">
+                <a:hlinkClick r:id="rId9"/>
+              </a:rPr>
+              <a:t>Protocol and ports. IANA service names and port numbers</a:t>
+            </a:r>
+            <a:r>
+              <a:rPr sz="1400"/>
+              <a:t>. last checked 2026-10</a:t>
+            </a:r>
+          </a:p>
+        </p:txBody>
+      </p:sp>
+    </p:spTree>
+  </p:cSld>
+  <p:clrMapOvr>
+    <a:masterClrMapping/>
+  </p:clrMapOvr>
+</p:sld>
+</file>
+
+<file path=ppt/slides/slide17.xml><?xml version="1.0" encoding="utf-8"?>
 <p:sld xmlns:a="http://schemas.openxmlformats.org/drawingml/2006/main" xmlns:p="http://schemas.openxmlformats.org/presentationml/2006/main" xmlns:r="http://schemas.openxmlformats.org/officeDocument/2006/relationships">
   <p:cSld>
     <p:spTree>

</xml_diff>